<commit_message>
Slide 10 : traduire les deux derniers intitules du gabarit
</commit_message>
<xml_diff>
--- a/deck-indabax.pptx
+++ b/deck-indabax.pptx
@@ -17740,7 +17740,7 @@
                 <a:cs typeface="Poppins Bold"/>
                 <a:sym typeface="Poppins Bold"/>
               </a:rPr>
-              <a:t>HANDS-ON EXERCISE</a:t>
+              <a:t>À VOUS</a:t>
             </a:r>
           </a:p>
         </p:txBody>
@@ -18387,7 +18387,7 @@
                 <a:cs typeface="Arimo"/>
                 <a:sym typeface="Arimo"/>
               </a:rPr>
-              <a:t>Materials: github.com/Arnel7/de-la-lettre-au-son</a:t>
+              <a:t>Tout est ici : github.com/Arnel7/de-la-lettre-au-son</a:t>
             </a:r>
           </a:p>
         </p:txBody>

</xml_diff>

<commit_message>
Slide 3 : ecrire les quatre phrases dans la grille
</commit_message>
<xml_diff>
--- a/deck-indabax.pptx
+++ b/deck-indabax.pptx
@@ -15113,7 +15113,7 @@
         </p:nvSpPr>
         <p:spPr>
           <a:xfrm>
-            <a:off x="6035040" y="3017520"/>
+            <a:off x="6035040" y="3200400"/>
             <a:ext cx="4754880" cy="411480"/>
           </a:xfrm>
           <a:prstGeom prst="rect">
@@ -15148,7 +15148,7 @@
         </p:nvSpPr>
         <p:spPr>
           <a:xfrm>
-            <a:off x="11338560" y="3017520"/>
+            <a:off x="11338560" y="3200400"/>
             <a:ext cx="4754880" cy="411480"/>
           </a:xfrm>
           <a:prstGeom prst="rect">
@@ -15183,8 +15183,8 @@
         </p:nvSpPr>
         <p:spPr>
           <a:xfrm>
-            <a:off x="1143000" y="3794760"/>
-            <a:ext cx="4572000" cy="1188720"/>
+            <a:off x="1143000" y="4206240"/>
+            <a:ext cx="4572000" cy="640080"/>
           </a:xfrm>
           <a:prstGeom prst="rect">
             <a:avLst/>
@@ -15218,8 +15218,8 @@
         </p:nvSpPr>
         <p:spPr>
           <a:xfrm>
-            <a:off x="6035040" y="3794760"/>
-            <a:ext cx="4754880" cy="1188720"/>
+            <a:off x="6035040" y="3703320"/>
+            <a:ext cx="4754880" cy="1645920"/>
           </a:xfrm>
           <a:prstGeom prst="roundRect">
             <a:avLst>
@@ -15266,8 +15266,8 @@
         </p:nvSpPr>
         <p:spPr>
           <a:xfrm>
-            <a:off x="6035040" y="3794760"/>
-            <a:ext cx="4754880" cy="1188720"/>
+            <a:off x="6217920" y="3849624"/>
+            <a:ext cx="4389120" cy="475488"/>
           </a:xfrm>
           <a:prstGeom prst="rect">
             <a:avLst/>
@@ -15282,6 +15282,41 @@
           <a:p>
             <a:pPr algn="ctr"/>
             <a:r>
+              <a:rPr sz="1600" b="1">
+                <a:solidFill>
+                  <a:srgbClr val="0A0A0A"/>
+                </a:solidFill>
+                <a:latin typeface="Arimo"/>
+              </a:rPr>
+              <a:t>bonjour et bienvenue à indabax bénin</a:t>
+            </a:r>
+          </a:p>
+        </p:txBody>
+      </p:sp>
+      <p:sp>
+        <p:nvSpPr>
+          <p:cNvPr id="23" name="TextBox 22"/>
+          <p:cNvSpPr txBox="1"/>
+          <p:nvPr/>
+        </p:nvSpPr>
+        <p:spPr>
+          <a:xfrm>
+            <a:off x="6035040" y="4636008"/>
+            <a:ext cx="4754880" cy="594360"/>
+          </a:xfrm>
+          <a:prstGeom prst="rect">
+            <a:avLst/>
+          </a:prstGeom>
+          <a:noFill/>
+        </p:spPr>
+        <p:txBody>
+          <a:bodyPr wrap="square" anchor="ctr">
+            <a:spAutoFit/>
+          </a:bodyPr>
+          <a:lstStyle/>
+          <a:p>
+            <a:pPr algn="ctr"/>
+            <a:r>
               <a:rPr sz="2400" b="1">
                 <a:solidFill>
                   <a:srgbClr val="008751"/>
@@ -15295,14 +15330,14 @@
       </p:sp>
       <p:sp>
         <p:nvSpPr>
-          <p:cNvPr id="23" name="Rounded Rectangle 22"/>
+          <p:cNvPr id="24" name="Rounded Rectangle 23"/>
           <p:cNvSpPr/>
           <p:nvPr/>
         </p:nvSpPr>
         <p:spPr>
           <a:xfrm>
-            <a:off x="11338559" y="3794760"/>
-            <a:ext cx="4754880" cy="1188720"/>
+            <a:off x="11338559" y="3703320"/>
+            <a:ext cx="4754880" cy="1645920"/>
           </a:xfrm>
           <a:prstGeom prst="roundRect">
             <a:avLst>
@@ -15343,14 +15378,14 @@
       </p:sp>
       <p:sp>
         <p:nvSpPr>
-          <p:cNvPr id="24" name="TextBox 23"/>
+          <p:cNvPr id="25" name="TextBox 24"/>
           <p:cNvSpPr txBox="1"/>
           <p:nvPr/>
         </p:nvSpPr>
         <p:spPr>
           <a:xfrm>
-            <a:off x="11338559" y="3794760"/>
-            <a:ext cx="4754880" cy="1188720"/>
+            <a:off x="11521439" y="3849624"/>
+            <a:ext cx="4389120" cy="475488"/>
           </a:xfrm>
           <a:prstGeom prst="rect">
             <a:avLst/>
@@ -15365,27 +15400,27 @@
           <a:p>
             <a:pPr algn="ctr"/>
             <a:r>
-              <a:rPr sz="2400" b="1">
-                <a:solidFill>
-                  <a:srgbClr val="E8112D"/>
-                </a:solidFill>
-                <a:latin typeface="Poppins"/>
-              </a:rPr>
-              <a:t>▶</a:t>
-            </a:r>
-          </a:p>
-        </p:txBody>
-      </p:sp>
-      <p:sp>
-        <p:nvSpPr>
-          <p:cNvPr id="25" name="TextBox 24"/>
+              <a:rPr sz="1600" b="1">
+                <a:solidFill>
+                  <a:srgbClr val="0A0A0A"/>
+                </a:solidFill>
+                <a:latin typeface="Arimo"/>
+              </a:rPr>
+              <a:t>les poules du couvent couvent</a:t>
+            </a:r>
+          </a:p>
+        </p:txBody>
+      </p:sp>
+      <p:sp>
+        <p:nvSpPr>
+          <p:cNvPr id="26" name="TextBox 25"/>
           <p:cNvSpPr txBox="1"/>
           <p:nvPr/>
         </p:nvSpPr>
         <p:spPr>
           <a:xfrm>
-            <a:off x="1143000" y="5486400"/>
-            <a:ext cx="4572000" cy="1188720"/>
+            <a:off x="11338559" y="4636008"/>
+            <a:ext cx="4754880" cy="594360"/>
           </a:xfrm>
           <a:prstGeom prst="rect">
             <a:avLst/>
@@ -15398,6 +15433,41 @@
           </a:bodyPr>
           <a:lstStyle/>
           <a:p>
+            <a:pPr algn="ctr"/>
+            <a:r>
+              <a:rPr sz="2400" b="1">
+                <a:solidFill>
+                  <a:srgbClr val="E8112D"/>
+                </a:solidFill>
+                <a:latin typeface="Poppins"/>
+              </a:rPr>
+              <a:t>▶</a:t>
+            </a:r>
+          </a:p>
+        </p:txBody>
+      </p:sp>
+      <p:sp>
+        <p:nvSpPr>
+          <p:cNvPr id="27" name="TextBox 26"/>
+          <p:cNvSpPr txBox="1"/>
+          <p:nvPr/>
+        </p:nvSpPr>
+        <p:spPr>
+          <a:xfrm>
+            <a:off x="1143000" y="6080759"/>
+            <a:ext cx="4572000" cy="640080"/>
+          </a:xfrm>
+          <a:prstGeom prst="rect">
+            <a:avLst/>
+          </a:prstGeom>
+          <a:noFill/>
+        </p:spPr>
+        <p:txBody>
+          <a:bodyPr wrap="square" anchor="ctr">
+            <a:spAutoFit/>
+          </a:bodyPr>
+          <a:lstStyle/>
+          <a:p>
             <a:pPr algn="l"/>
             <a:r>
               <a:rPr sz="2600" b="1">
@@ -15413,14 +15483,14 @@
       </p:sp>
       <p:sp>
         <p:nvSpPr>
-          <p:cNvPr id="26" name="Rounded Rectangle 25"/>
+          <p:cNvPr id="28" name="Rounded Rectangle 27"/>
           <p:cNvSpPr/>
           <p:nvPr/>
         </p:nvSpPr>
         <p:spPr>
           <a:xfrm>
-            <a:off x="6035040" y="5486400"/>
-            <a:ext cx="4754880" cy="1188720"/>
+            <a:off x="6035040" y="5577840"/>
+            <a:ext cx="4754880" cy="1645920"/>
           </a:xfrm>
           <a:prstGeom prst="roundRect">
             <a:avLst>
@@ -15461,14 +15531,14 @@
       </p:sp>
       <p:sp>
         <p:nvSpPr>
-          <p:cNvPr id="27" name="TextBox 26"/>
+          <p:cNvPr id="29" name="TextBox 28"/>
           <p:cNvSpPr txBox="1"/>
           <p:nvPr/>
         </p:nvSpPr>
         <p:spPr>
           <a:xfrm>
-            <a:off x="6035040" y="5486400"/>
-            <a:ext cx="4754880" cy="1188720"/>
+            <a:off x="6217920" y="5724144"/>
+            <a:ext cx="4389120" cy="475488"/>
           </a:xfrm>
           <a:prstGeom prst="rect">
             <a:avLst/>
@@ -15483,6 +15553,76 @@
           <a:p>
             <a:pPr algn="ctr"/>
             <a:r>
+              <a:rPr sz="1600" b="1">
+                <a:solidFill>
+                  <a:srgbClr val="0A0A0A"/>
+                </a:solidFill>
+                <a:latin typeface="Arimo"/>
+              </a:rPr>
+              <a:t>E ɖɔ nu mi</a:t>
+            </a:r>
+          </a:p>
+        </p:txBody>
+      </p:sp>
+      <p:sp>
+        <p:nvSpPr>
+          <p:cNvPr id="30" name="TextBox 29"/>
+          <p:cNvSpPr txBox="1"/>
+          <p:nvPr/>
+        </p:nvSpPr>
+        <p:spPr>
+          <a:xfrm>
+            <a:off x="6217920" y="6181344"/>
+            <a:ext cx="4389120" cy="292608"/>
+          </a:xfrm>
+          <a:prstGeom prst="rect">
+            <a:avLst/>
+          </a:prstGeom>
+          <a:noFill/>
+        </p:spPr>
+        <p:txBody>
+          <a:bodyPr wrap="square" anchor="ctr">
+            <a:spAutoFit/>
+          </a:bodyPr>
+          <a:lstStyle/>
+          <a:p>
+            <a:pPr algn="ctr"/>
+            <a:r>
+              <a:rPr sz="1200" b="0">
+                <a:solidFill>
+                  <a:srgbClr val="5B5B5B"/>
+                </a:solidFill>
+                <a:latin typeface="Arimo"/>
+              </a:rPr>
+              <a:t>sans les tons</a:t>
+            </a:r>
+          </a:p>
+        </p:txBody>
+      </p:sp>
+      <p:sp>
+        <p:nvSpPr>
+          <p:cNvPr id="31" name="TextBox 30"/>
+          <p:cNvSpPr txBox="1"/>
+          <p:nvPr/>
+        </p:nvSpPr>
+        <p:spPr>
+          <a:xfrm>
+            <a:off x="6035040" y="6510527"/>
+            <a:ext cx="4754880" cy="594360"/>
+          </a:xfrm>
+          <a:prstGeom prst="rect">
+            <a:avLst/>
+          </a:prstGeom>
+          <a:noFill/>
+        </p:spPr>
+        <p:txBody>
+          <a:bodyPr wrap="square" anchor="ctr">
+            <a:spAutoFit/>
+          </a:bodyPr>
+          <a:lstStyle/>
+          <a:p>
+            <a:pPr algn="ctr"/>
+            <a:r>
               <a:rPr sz="2400" b="1">
                 <a:solidFill>
                   <a:srgbClr val="008751"/>
@@ -15496,14 +15636,14 @@
       </p:sp>
       <p:sp>
         <p:nvSpPr>
-          <p:cNvPr id="28" name="Rounded Rectangle 27"/>
+          <p:cNvPr id="32" name="Rounded Rectangle 31"/>
           <p:cNvSpPr/>
           <p:nvPr/>
         </p:nvSpPr>
         <p:spPr>
           <a:xfrm>
-            <a:off x="11338559" y="5486400"/>
-            <a:ext cx="4754880" cy="1188720"/>
+            <a:off x="11338559" y="5577840"/>
+            <a:ext cx="4754880" cy="1645920"/>
           </a:xfrm>
           <a:prstGeom prst="roundRect">
             <a:avLst>
@@ -15544,14 +15684,14 @@
       </p:sp>
       <p:sp>
         <p:nvSpPr>
-          <p:cNvPr id="29" name="TextBox 28"/>
+          <p:cNvPr id="33" name="TextBox 32"/>
           <p:cNvSpPr txBox="1"/>
           <p:nvPr/>
         </p:nvSpPr>
         <p:spPr>
           <a:xfrm>
-            <a:off x="11338559" y="5486400"/>
-            <a:ext cx="4754880" cy="1188720"/>
+            <a:off x="11521439" y="5724144"/>
+            <a:ext cx="4389120" cy="475488"/>
           </a:xfrm>
           <a:prstGeom prst="rect">
             <a:avLst/>
@@ -15566,6 +15706,76 @@
           <a:p>
             <a:pPr algn="ctr"/>
             <a:r>
+              <a:rPr sz="1600" b="1">
+                <a:solidFill>
+                  <a:srgbClr val="0A0A0A"/>
+                </a:solidFill>
+                <a:latin typeface="Arimo"/>
+              </a:rPr>
+              <a:t>É ɖɔ̀ nú mì</a:t>
+            </a:r>
+          </a:p>
+        </p:txBody>
+      </p:sp>
+      <p:sp>
+        <p:nvSpPr>
+          <p:cNvPr id="34" name="TextBox 33"/>
+          <p:cNvSpPr txBox="1"/>
+          <p:nvPr/>
+        </p:nvSpPr>
+        <p:spPr>
+          <a:xfrm>
+            <a:off x="11521439" y="6181344"/>
+            <a:ext cx="4389120" cy="292608"/>
+          </a:xfrm>
+          <a:prstGeom prst="rect">
+            <a:avLst/>
+          </a:prstGeom>
+          <a:noFill/>
+        </p:spPr>
+        <p:txBody>
+          <a:bodyPr wrap="square" anchor="ctr">
+            <a:spAutoFit/>
+          </a:bodyPr>
+          <a:lstStyle/>
+          <a:p>
+            <a:pPr algn="ctr"/>
+            <a:r>
+              <a:rPr sz="1200" b="0">
+                <a:solidFill>
+                  <a:srgbClr val="5B5B5B"/>
+                </a:solidFill>
+                <a:latin typeface="Arimo"/>
+              </a:rPr>
+              <a:t>les tons écrits</a:t>
+            </a:r>
+          </a:p>
+        </p:txBody>
+      </p:sp>
+      <p:sp>
+        <p:nvSpPr>
+          <p:cNvPr id="35" name="TextBox 34"/>
+          <p:cNvSpPr txBox="1"/>
+          <p:nvPr/>
+        </p:nvSpPr>
+        <p:spPr>
+          <a:xfrm>
+            <a:off x="11338559" y="6510527"/>
+            <a:ext cx="4754880" cy="594360"/>
+          </a:xfrm>
+          <a:prstGeom prst="rect">
+            <a:avLst/>
+          </a:prstGeom>
+          <a:noFill/>
+        </p:spPr>
+        <p:txBody>
+          <a:bodyPr wrap="square" anchor="ctr">
+            <a:spAutoFit/>
+          </a:bodyPr>
+          <a:lstStyle/>
+          <a:p>
+            <a:pPr algn="ctr"/>
+            <a:r>
               <a:rPr sz="2400" b="1">
                 <a:solidFill>
                   <a:srgbClr val="E8112D"/>
@@ -15579,13 +15789,13 @@
       </p:sp>
       <p:sp>
         <p:nvSpPr>
-          <p:cNvPr id="30" name="TextBox 29"/>
+          <p:cNvPr id="36" name="TextBox 35"/>
           <p:cNvSpPr txBox="1"/>
           <p:nvPr/>
         </p:nvSpPr>
         <p:spPr>
           <a:xfrm>
-            <a:off x="1143000" y="6675120"/>
+            <a:off x="1143000" y="7543800"/>
             <a:ext cx="16002000" cy="731520"/>
           </a:xfrm>
           <a:prstGeom prst="rect">

</xml_diff>

<commit_message>
Creneau confirme : 60 minutes, track B2, salle PREFAB
</commit_message>
<xml_diff>
--- a/deck-indabax.pptx
+++ b/deck-indabax.pptx
@@ -13853,7 +13853,7 @@
         <p:spPr>
           <a:xfrm rot="0">
             <a:off x="16469582" y="3375565"/>
-            <a:ext cx="675418" cy="457200"/>
+            <a:ext cx="1097280" cy="457200"/>
           </a:xfrm>
           <a:prstGeom prst="rect">
             <a:avLst/>
@@ -13880,7 +13880,7 @@
                 <a:cs typeface="Arimo"/>
                 <a:sym typeface="Arimo"/>
               </a:rPr>
-              <a:t>10 min</a:t>
+              <a:t>13 min</a:t>
             </a:r>
           </a:p>
         </p:txBody>
@@ -14026,7 +14026,7 @@
                 <a:cs typeface="Arimo"/>
                 <a:sym typeface="Arimo"/>
               </a:rPr>
-              <a:t>20 min</a:t>
+              <a:t>3 min</a:t>
             </a:r>
           </a:p>
         </p:txBody>
@@ -14172,7 +14172,7 @@
                 <a:cs typeface="Arimo"/>
                 <a:sym typeface="Arimo"/>
               </a:rPr>
-              <a:t>30 min</a:t>
+              <a:t>32 min</a:t>
             </a:r>
           </a:p>
         </p:txBody>
@@ -14318,7 +14318,7 @@
                 <a:cs typeface="Arimo"/>
                 <a:sym typeface="Arimo"/>
               </a:rPr>
-              <a:t>10 min</a:t>
+              <a:t>12 min</a:t>
             </a:r>
           </a:p>
         </p:txBody>

</xml_diff>

<commit_message>
Aligner la duree de la pratique : agenda et slide 10
</commit_message>
<xml_diff>
--- a/deck-indabax.pptx
+++ b/deck-indabax.pptx
@@ -14172,7 +14172,7 @@
                 <a:cs typeface="Arimo"/>
                 <a:sym typeface="Arimo"/>
               </a:rPr>
-              <a:t>32 min</a:t>
+              <a:t>30 min</a:t>
             </a:r>
           </a:p>
         </p:txBody>
@@ -14318,7 +14318,7 @@
                 <a:cs typeface="Arimo"/>
                 <a:sym typeface="Arimo"/>
               </a:rPr>
-              <a:t>12 min</a:t>
+              <a:t>14 min</a:t>
             </a:r>
           </a:p>
         </p:txBody>
@@ -18064,7 +18064,7 @@
                   <a:cs typeface="Arimo Bold"/>
                   <a:sym typeface="Arimo Bold"/>
                 </a:rPr>
-                <a:t>25 minutes</a:t>
+                <a:t>30 minutes</a:t>
               </a:r>
             </a:p>
           </p:txBody>

</xml_diff>